<commit_message>
Fiches outils: Section Mill, Whipstock et mises à jour
Co-Authored-By: Claude Sonnet 5.5 <noreply@anthropic.com>
Claude-Session: https://claude.ai/code/session_01XPwnZBmWUGhvYebrP3X3Z2
</commit_message>
<xml_diff>
--- a/fiches_outils/Fiche_technique_MWD.pptx
+++ b/fiches_outils/Fiche_technique_MWD.pptx
@@ -3591,7 +3591,7 @@
         </p:nvGraphicFramePr>
         <p:xfrm>
           <a:off x="711200" y="5168900"/>
-          <a:ext cx="3009900" cy="1889760"/>
+          <a:ext cx="3009900" cy="2042160"/>
         </p:xfrm>
         <a:graphic>
           <a:graphicData uri="http://schemas.openxmlformats.org/drawingml/2006/table">
@@ -3601,7 +3601,7 @@
                 <a:gridCol w="1041400"/>
                 <a:gridCol w="1968500"/>
               </a:tblGrid>
-              <a:tr h="157480">
+              <a:tr h="170180">
                 <a:tc>
                   <a:txBody>
                     <a:bodyPr wrap="square"/>
@@ -3609,11 +3609,11 @@
                     <a:p>
                       <a:pPr algn="l">
                         <a:lnSpc>
-                          <a:spcPts val="800"/>
+                          <a:spcPts val="860"/>
                         </a:lnSpc>
                       </a:pPr>
                       <a:r>
-                        <a:rPr sz="640" b="0">
+                        <a:rPr sz="700" b="0">
                           <a:solidFill>
                             <a:srgbClr val="FEFEFF"/>
                           </a:solidFill>
@@ -3663,11 +3663,11 @@
                     <a:p>
                       <a:pPr algn="l">
                         <a:lnSpc>
-                          <a:spcPts val="800"/>
+                          <a:spcPts val="860"/>
                         </a:lnSpc>
                       </a:pPr>
                       <a:r>
-                        <a:rPr sz="640" b="0">
+                        <a:rPr sz="700" b="0">
                           <a:solidFill>
                             <a:srgbClr val="000000"/>
                           </a:solidFill>
@@ -3711,7 +3711,7 @@
                   </a:tcPr>
                 </a:tc>
               </a:tr>
-              <a:tr h="157480">
+              <a:tr h="170180">
                 <a:tc>
                   <a:txBody>
                     <a:bodyPr wrap="square"/>
@@ -3719,11 +3719,11 @@
                     <a:p>
                       <a:pPr algn="l">
                         <a:lnSpc>
-                          <a:spcPts val="800"/>
+                          <a:spcPts val="860"/>
                         </a:lnSpc>
                       </a:pPr>
                       <a:r>
-                        <a:rPr sz="640" b="0">
+                        <a:rPr sz="700" b="0">
                           <a:solidFill>
                             <a:srgbClr val="FEFEFF"/>
                           </a:solidFill>
@@ -3773,11 +3773,11 @@
                     <a:p>
                       <a:pPr algn="l">
                         <a:lnSpc>
-                          <a:spcPts val="800"/>
+                          <a:spcPts val="860"/>
                         </a:lnSpc>
                       </a:pPr>
                       <a:r>
-                        <a:rPr sz="640" b="0">
+                        <a:rPr sz="700" b="0">
                           <a:solidFill>
                             <a:srgbClr val="000000"/>
                           </a:solidFill>
@@ -3821,7 +3821,7 @@
                   </a:tcPr>
                 </a:tc>
               </a:tr>
-              <a:tr h="157480">
+              <a:tr h="170180">
                 <a:tc>
                   <a:txBody>
                     <a:bodyPr wrap="square"/>
@@ -3829,11 +3829,11 @@
                     <a:p>
                       <a:pPr algn="l">
                         <a:lnSpc>
-                          <a:spcPts val="800"/>
+                          <a:spcPts val="860"/>
                         </a:lnSpc>
                       </a:pPr>
                       <a:r>
-                        <a:rPr sz="640" b="0">
+                        <a:rPr sz="700" b="0">
                           <a:solidFill>
                             <a:srgbClr val="FEFEFF"/>
                           </a:solidFill>
@@ -3883,11 +3883,11 @@
                     <a:p>
                       <a:pPr algn="l">
                         <a:lnSpc>
-                          <a:spcPts val="800"/>
+                          <a:spcPts val="860"/>
                         </a:lnSpc>
                       </a:pPr>
                       <a:r>
-                        <a:rPr sz="640" b="0">
+                        <a:rPr sz="700" b="0">
                           <a:solidFill>
                             <a:srgbClr val="000000"/>
                           </a:solidFill>
@@ -3931,7 +3931,7 @@
                   </a:tcPr>
                 </a:tc>
               </a:tr>
-              <a:tr h="157480">
+              <a:tr h="170180">
                 <a:tc>
                   <a:txBody>
                     <a:bodyPr wrap="square"/>
@@ -3939,11 +3939,11 @@
                     <a:p>
                       <a:pPr algn="l">
                         <a:lnSpc>
-                          <a:spcPts val="800"/>
+                          <a:spcPts val="860"/>
                         </a:lnSpc>
                       </a:pPr>
                       <a:r>
-                        <a:rPr sz="640" b="0">
+                        <a:rPr sz="700" b="0">
                           <a:solidFill>
                             <a:srgbClr val="FEFEFF"/>
                           </a:solidFill>
@@ -3993,11 +3993,11 @@
                     <a:p>
                       <a:pPr algn="l">
                         <a:lnSpc>
-                          <a:spcPts val="800"/>
+                          <a:spcPts val="860"/>
                         </a:lnSpc>
                       </a:pPr>
                       <a:r>
-                        <a:rPr sz="640" b="0">
+                        <a:rPr sz="700" b="0">
                           <a:solidFill>
                             <a:srgbClr val="000000"/>
                           </a:solidFill>
@@ -4041,7 +4041,7 @@
                   </a:tcPr>
                 </a:tc>
               </a:tr>
-              <a:tr h="157480">
+              <a:tr h="170180">
                 <a:tc>
                   <a:txBody>
                     <a:bodyPr wrap="square"/>
@@ -4049,11 +4049,11 @@
                     <a:p>
                       <a:pPr algn="l">
                         <a:lnSpc>
-                          <a:spcPts val="800"/>
+                          <a:spcPts val="860"/>
                         </a:lnSpc>
                       </a:pPr>
                       <a:r>
-                        <a:rPr sz="640" b="0">
+                        <a:rPr sz="700" b="0">
                           <a:solidFill>
                             <a:srgbClr val="FEFEFF"/>
                           </a:solidFill>
@@ -4103,11 +4103,11 @@
                     <a:p>
                       <a:pPr algn="l">
                         <a:lnSpc>
-                          <a:spcPts val="800"/>
+                          <a:spcPts val="860"/>
                         </a:lnSpc>
                       </a:pPr>
                       <a:r>
-                        <a:rPr sz="640" b="0">
+                        <a:rPr sz="700" b="0">
                           <a:solidFill>
                             <a:srgbClr val="000000"/>
                           </a:solidFill>
@@ -4151,7 +4151,7 @@
                   </a:tcPr>
                 </a:tc>
               </a:tr>
-              <a:tr h="157480">
+              <a:tr h="170180">
                 <a:tc>
                   <a:txBody>
                     <a:bodyPr wrap="square"/>
@@ -4159,11 +4159,11 @@
                     <a:p>
                       <a:pPr algn="l">
                         <a:lnSpc>
-                          <a:spcPts val="800"/>
+                          <a:spcPts val="860"/>
                         </a:lnSpc>
                       </a:pPr>
                       <a:r>
-                        <a:rPr sz="640" b="0">
+                        <a:rPr sz="700" b="0">
                           <a:solidFill>
                             <a:srgbClr val="FEFEFF"/>
                           </a:solidFill>
@@ -4213,11 +4213,11 @@
                     <a:p>
                       <a:pPr algn="l">
                         <a:lnSpc>
-                          <a:spcPts val="800"/>
+                          <a:spcPts val="860"/>
                         </a:lnSpc>
                       </a:pPr>
                       <a:r>
-                        <a:rPr sz="640" b="0">
+                        <a:rPr sz="700" b="0">
                           <a:solidFill>
                             <a:srgbClr val="000000"/>
                           </a:solidFill>
@@ -4261,7 +4261,7 @@
                   </a:tcPr>
                 </a:tc>
               </a:tr>
-              <a:tr h="157480">
+              <a:tr h="170180">
                 <a:tc>
                   <a:txBody>
                     <a:bodyPr wrap="square"/>
@@ -4269,11 +4269,11 @@
                     <a:p>
                       <a:pPr algn="l">
                         <a:lnSpc>
-                          <a:spcPts val="800"/>
+                          <a:spcPts val="860"/>
                         </a:lnSpc>
                       </a:pPr>
                       <a:r>
-                        <a:rPr sz="640" b="0">
+                        <a:rPr sz="700" b="0">
                           <a:solidFill>
                             <a:srgbClr val="FEFEFF"/>
                           </a:solidFill>
@@ -4323,11 +4323,11 @@
                     <a:p>
                       <a:pPr algn="l">
                         <a:lnSpc>
-                          <a:spcPts val="800"/>
+                          <a:spcPts val="860"/>
                         </a:lnSpc>
                       </a:pPr>
                       <a:r>
-                        <a:rPr sz="640" b="0">
+                        <a:rPr sz="700" b="0">
                           <a:solidFill>
                             <a:srgbClr val="000000"/>
                           </a:solidFill>
@@ -4371,7 +4371,7 @@
                   </a:tcPr>
                 </a:tc>
               </a:tr>
-              <a:tr h="157480">
+              <a:tr h="170180">
                 <a:tc>
                   <a:txBody>
                     <a:bodyPr wrap="square"/>
@@ -4379,11 +4379,11 @@
                     <a:p>
                       <a:pPr algn="l">
                         <a:lnSpc>
-                          <a:spcPts val="800"/>
+                          <a:spcPts val="860"/>
                         </a:lnSpc>
                       </a:pPr>
                       <a:r>
-                        <a:rPr sz="640" b="0">
+                        <a:rPr sz="700" b="0">
                           <a:solidFill>
                             <a:srgbClr val="FEFEFF"/>
                           </a:solidFill>
@@ -4433,11 +4433,11 @@
                     <a:p>
                       <a:pPr algn="l">
                         <a:lnSpc>
-                          <a:spcPts val="800"/>
+                          <a:spcPts val="860"/>
                         </a:lnSpc>
                       </a:pPr>
                       <a:r>
-                        <a:rPr sz="640" b="0">
+                        <a:rPr sz="700" b="0">
                           <a:solidFill>
                             <a:srgbClr val="000000"/>
                           </a:solidFill>
@@ -4481,7 +4481,7 @@
                   </a:tcPr>
                 </a:tc>
               </a:tr>
-              <a:tr h="157480">
+              <a:tr h="170180">
                 <a:tc>
                   <a:txBody>
                     <a:bodyPr wrap="square"/>
@@ -4489,11 +4489,11 @@
                     <a:p>
                       <a:pPr algn="l">
                         <a:lnSpc>
-                          <a:spcPts val="800"/>
+                          <a:spcPts val="860"/>
                         </a:lnSpc>
                       </a:pPr>
                       <a:r>
-                        <a:rPr sz="640" b="0">
+                        <a:rPr sz="700" b="0">
                           <a:solidFill>
                             <a:srgbClr val="FEFEFF"/>
                           </a:solidFill>
@@ -4543,11 +4543,11 @@
                     <a:p>
                       <a:pPr algn="l">
                         <a:lnSpc>
-                          <a:spcPts val="800"/>
+                          <a:spcPts val="860"/>
                         </a:lnSpc>
                       </a:pPr>
                       <a:r>
-                        <a:rPr sz="640" b="0">
+                        <a:rPr sz="700" b="0">
                           <a:solidFill>
                             <a:srgbClr val="000000"/>
                           </a:solidFill>
@@ -4591,7 +4591,7 @@
                   </a:tcPr>
                 </a:tc>
               </a:tr>
-              <a:tr h="157480">
+              <a:tr h="170180">
                 <a:tc>
                   <a:txBody>
                     <a:bodyPr wrap="square"/>
@@ -4599,11 +4599,11 @@
                     <a:p>
                       <a:pPr algn="l">
                         <a:lnSpc>
-                          <a:spcPts val="800"/>
+                          <a:spcPts val="860"/>
                         </a:lnSpc>
                       </a:pPr>
                       <a:r>
-                        <a:rPr sz="640" b="0">
+                        <a:rPr sz="700" b="0">
                           <a:solidFill>
                             <a:srgbClr val="FEFEFF"/>
                           </a:solidFill>
@@ -4653,11 +4653,11 @@
                     <a:p>
                       <a:pPr algn="l">
                         <a:lnSpc>
-                          <a:spcPts val="800"/>
+                          <a:spcPts val="860"/>
                         </a:lnSpc>
                       </a:pPr>
                       <a:r>
-                        <a:rPr sz="640" b="0">
+                        <a:rPr sz="700" b="0">
                           <a:solidFill>
                             <a:srgbClr val="000000"/>
                           </a:solidFill>
@@ -4701,7 +4701,7 @@
                   </a:tcPr>
                 </a:tc>
               </a:tr>
-              <a:tr h="157480">
+              <a:tr h="170180">
                 <a:tc>
                   <a:txBody>
                     <a:bodyPr wrap="square"/>
@@ -4709,11 +4709,11 @@
                     <a:p>
                       <a:pPr algn="l">
                         <a:lnSpc>
-                          <a:spcPts val="800"/>
+                          <a:spcPts val="860"/>
                         </a:lnSpc>
                       </a:pPr>
                       <a:r>
-                        <a:rPr sz="640" b="0">
+                        <a:rPr sz="700" b="0">
                           <a:solidFill>
                             <a:srgbClr val="FEFEFF"/>
                           </a:solidFill>
@@ -4763,11 +4763,11 @@
                     <a:p>
                       <a:pPr algn="l">
                         <a:lnSpc>
-                          <a:spcPts val="800"/>
+                          <a:spcPts val="860"/>
                         </a:lnSpc>
                       </a:pPr>
                       <a:r>
-                        <a:rPr sz="640" b="0">
+                        <a:rPr sz="700" b="0">
                           <a:solidFill>
                             <a:srgbClr val="000000"/>
                           </a:solidFill>
@@ -4811,7 +4811,7 @@
                   </a:tcPr>
                 </a:tc>
               </a:tr>
-              <a:tr h="157480">
+              <a:tr h="170180">
                 <a:tc>
                   <a:txBody>
                     <a:bodyPr wrap="square"/>
@@ -4819,11 +4819,11 @@
                     <a:p>
                       <a:pPr algn="l">
                         <a:lnSpc>
-                          <a:spcPts val="800"/>
+                          <a:spcPts val="860"/>
                         </a:lnSpc>
                       </a:pPr>
                       <a:r>
-                        <a:rPr sz="640" b="0">
+                        <a:rPr sz="700" b="0">
                           <a:solidFill>
                             <a:srgbClr val="FEFEFF"/>
                           </a:solidFill>
@@ -4873,11 +4873,11 @@
                     <a:p>
                       <a:pPr algn="l">
                         <a:lnSpc>
-                          <a:spcPts val="800"/>
+                          <a:spcPts val="860"/>
                         </a:lnSpc>
                       </a:pPr>
                       <a:r>
-                        <a:rPr sz="640" b="0">
+                        <a:rPr sz="700" b="0">
                           <a:solidFill>
                             <a:srgbClr val="000000"/>
                           </a:solidFill>
@@ -4935,7 +4935,7 @@
         </p:nvGraphicFramePr>
         <p:xfrm>
           <a:off x="3835400" y="5168900"/>
-          <a:ext cx="3009900" cy="1889760"/>
+          <a:ext cx="3009900" cy="2042160"/>
         </p:xfrm>
         <a:graphic>
           <a:graphicData uri="http://schemas.openxmlformats.org/drawingml/2006/table">
@@ -4945,7 +4945,7 @@
                 <a:gridCol w="1117600"/>
                 <a:gridCol w="1892300"/>
               </a:tblGrid>
-              <a:tr h="157480">
+              <a:tr h="170180">
                 <a:tc>
                   <a:txBody>
                     <a:bodyPr wrap="square"/>
@@ -4953,11 +4953,11 @@
                     <a:p>
                       <a:pPr algn="l">
                         <a:lnSpc>
-                          <a:spcPts val="800"/>
+                          <a:spcPts val="860"/>
                         </a:lnSpc>
                       </a:pPr>
                       <a:r>
-                        <a:rPr sz="640" b="0">
+                        <a:rPr sz="700" b="0">
                           <a:solidFill>
                             <a:srgbClr val="FEFEFF"/>
                           </a:solidFill>
@@ -5007,11 +5007,11 @@
                     <a:p>
                       <a:pPr algn="l">
                         <a:lnSpc>
-                          <a:spcPts val="800"/>
+                          <a:spcPts val="860"/>
                         </a:lnSpc>
                       </a:pPr>
                       <a:r>
-                        <a:rPr sz="640" b="0">
+                        <a:rPr sz="700" b="0">
                           <a:solidFill>
                             <a:srgbClr val="000000"/>
                           </a:solidFill>
@@ -5055,7 +5055,7 @@
                   </a:tcPr>
                 </a:tc>
               </a:tr>
-              <a:tr h="157480">
+              <a:tr h="170180">
                 <a:tc>
                   <a:txBody>
                     <a:bodyPr wrap="square"/>
@@ -5063,11 +5063,11 @@
                     <a:p>
                       <a:pPr algn="l">
                         <a:lnSpc>
-                          <a:spcPts val="800"/>
+                          <a:spcPts val="860"/>
                         </a:lnSpc>
                       </a:pPr>
                       <a:r>
-                        <a:rPr sz="640" b="0">
+                        <a:rPr sz="700" b="0">
                           <a:solidFill>
                             <a:srgbClr val="FEFEFF"/>
                           </a:solidFill>
@@ -5117,11 +5117,11 @@
                     <a:p>
                       <a:pPr algn="l">
                         <a:lnSpc>
-                          <a:spcPts val="800"/>
+                          <a:spcPts val="860"/>
                         </a:lnSpc>
                       </a:pPr>
                       <a:r>
-                        <a:rPr sz="640" b="0">
+                        <a:rPr sz="700" b="0">
                           <a:solidFill>
                             <a:srgbClr val="000000"/>
                           </a:solidFill>
@@ -5165,7 +5165,7 @@
                   </a:tcPr>
                 </a:tc>
               </a:tr>
-              <a:tr h="157480">
+              <a:tr h="170180">
                 <a:tc>
                   <a:txBody>
                     <a:bodyPr wrap="square"/>
@@ -5173,11 +5173,11 @@
                     <a:p>
                       <a:pPr algn="l">
                         <a:lnSpc>
-                          <a:spcPts val="800"/>
+                          <a:spcPts val="860"/>
                         </a:lnSpc>
                       </a:pPr>
                       <a:r>
-                        <a:rPr sz="640" b="0">
+                        <a:rPr sz="700" b="0">
                           <a:solidFill>
                             <a:srgbClr val="FEFEFF"/>
                           </a:solidFill>
@@ -5227,11 +5227,11 @@
                     <a:p>
                       <a:pPr algn="l">
                         <a:lnSpc>
-                          <a:spcPts val="800"/>
+                          <a:spcPts val="860"/>
                         </a:lnSpc>
                       </a:pPr>
                       <a:r>
-                        <a:rPr sz="640" b="0">
+                        <a:rPr sz="700" b="0">
                           <a:solidFill>
                             <a:srgbClr val="000000"/>
                           </a:solidFill>
@@ -5275,7 +5275,7 @@
                   </a:tcPr>
                 </a:tc>
               </a:tr>
-              <a:tr h="157480">
+              <a:tr h="170180">
                 <a:tc>
                   <a:txBody>
                     <a:bodyPr wrap="square"/>
@@ -5283,11 +5283,11 @@
                     <a:p>
                       <a:pPr algn="l">
                         <a:lnSpc>
-                          <a:spcPts val="800"/>
+                          <a:spcPts val="860"/>
                         </a:lnSpc>
                       </a:pPr>
                       <a:r>
-                        <a:rPr sz="640" b="0">
+                        <a:rPr sz="700" b="0">
                           <a:solidFill>
                             <a:srgbClr val="FEFEFF"/>
                           </a:solidFill>
@@ -5337,11 +5337,11 @@
                     <a:p>
                       <a:pPr algn="l">
                         <a:lnSpc>
-                          <a:spcPts val="800"/>
+                          <a:spcPts val="860"/>
                         </a:lnSpc>
                       </a:pPr>
                       <a:r>
-                        <a:rPr sz="640" b="0">
+                        <a:rPr sz="700" b="0">
                           <a:solidFill>
                             <a:srgbClr val="000000"/>
                           </a:solidFill>
@@ -5385,7 +5385,7 @@
                   </a:tcPr>
                 </a:tc>
               </a:tr>
-              <a:tr h="157480">
+              <a:tr h="170180">
                 <a:tc>
                   <a:txBody>
                     <a:bodyPr wrap="square"/>
@@ -5393,11 +5393,11 @@
                     <a:p>
                       <a:pPr algn="l">
                         <a:lnSpc>
-                          <a:spcPts val="800"/>
+                          <a:spcPts val="860"/>
                         </a:lnSpc>
                       </a:pPr>
                       <a:r>
-                        <a:rPr sz="640" b="0">
+                        <a:rPr sz="700" b="0">
                           <a:solidFill>
                             <a:srgbClr val="FEFEFF"/>
                           </a:solidFill>
@@ -5447,11 +5447,11 @@
                     <a:p>
                       <a:pPr algn="l">
                         <a:lnSpc>
-                          <a:spcPts val="800"/>
+                          <a:spcPts val="860"/>
                         </a:lnSpc>
                       </a:pPr>
                       <a:r>
-                        <a:rPr sz="640" b="0">
+                        <a:rPr sz="700" b="0">
                           <a:solidFill>
                             <a:srgbClr val="000000"/>
                           </a:solidFill>
@@ -5495,7 +5495,7 @@
                   </a:tcPr>
                 </a:tc>
               </a:tr>
-              <a:tr h="157480">
+              <a:tr h="170180">
                 <a:tc>
                   <a:txBody>
                     <a:bodyPr wrap="square"/>
@@ -5503,11 +5503,11 @@
                     <a:p>
                       <a:pPr algn="l">
                         <a:lnSpc>
-                          <a:spcPts val="800"/>
+                          <a:spcPts val="860"/>
                         </a:lnSpc>
                       </a:pPr>
                       <a:r>
-                        <a:rPr sz="640" b="0">
+                        <a:rPr sz="700" b="0">
                           <a:solidFill>
                             <a:srgbClr val="FEFEFF"/>
                           </a:solidFill>
@@ -5557,11 +5557,11 @@
                     <a:p>
                       <a:pPr algn="l">
                         <a:lnSpc>
-                          <a:spcPts val="800"/>
+                          <a:spcPts val="860"/>
                         </a:lnSpc>
                       </a:pPr>
                       <a:r>
-                        <a:rPr sz="640" b="0">
+                        <a:rPr sz="700" b="0">
                           <a:solidFill>
                             <a:srgbClr val="000000"/>
                           </a:solidFill>
@@ -5605,7 +5605,7 @@
                   </a:tcPr>
                 </a:tc>
               </a:tr>
-              <a:tr h="157480">
+              <a:tr h="170180">
                 <a:tc>
                   <a:txBody>
                     <a:bodyPr wrap="square"/>
@@ -5613,11 +5613,11 @@
                     <a:p>
                       <a:pPr algn="l">
                         <a:lnSpc>
-                          <a:spcPts val="800"/>
+                          <a:spcPts val="860"/>
                         </a:lnSpc>
                       </a:pPr>
                       <a:r>
-                        <a:rPr sz="640" b="0">
+                        <a:rPr sz="700" b="0">
                           <a:solidFill>
                             <a:srgbClr val="FEFEFF"/>
                           </a:solidFill>
@@ -5667,11 +5667,11 @@
                     <a:p>
                       <a:pPr algn="l">
                         <a:lnSpc>
-                          <a:spcPts val="800"/>
+                          <a:spcPts val="860"/>
                         </a:lnSpc>
                       </a:pPr>
                       <a:r>
-                        <a:rPr sz="640" b="0">
+                        <a:rPr sz="700" b="0">
                           <a:solidFill>
                             <a:srgbClr val="000000"/>
                           </a:solidFill>
@@ -5715,7 +5715,7 @@
                   </a:tcPr>
                 </a:tc>
               </a:tr>
-              <a:tr h="157480">
+              <a:tr h="170180">
                 <a:tc>
                   <a:txBody>
                     <a:bodyPr wrap="square"/>
@@ -5723,11 +5723,11 @@
                     <a:p>
                       <a:pPr algn="l">
                         <a:lnSpc>
-                          <a:spcPts val="800"/>
+                          <a:spcPts val="860"/>
                         </a:lnSpc>
                       </a:pPr>
                       <a:r>
-                        <a:rPr sz="640" b="0">
+                        <a:rPr sz="700" b="0">
                           <a:solidFill>
                             <a:srgbClr val="FEFEFF"/>
                           </a:solidFill>
@@ -5777,11 +5777,11 @@
                     <a:p>
                       <a:pPr algn="l">
                         <a:lnSpc>
-                          <a:spcPts val="800"/>
+                          <a:spcPts val="860"/>
                         </a:lnSpc>
                       </a:pPr>
                       <a:r>
-                        <a:rPr sz="640" b="0">
+                        <a:rPr sz="700" b="0">
                           <a:solidFill>
                             <a:srgbClr val="000000"/>
                           </a:solidFill>
@@ -5825,7 +5825,7 @@
                   </a:tcPr>
                 </a:tc>
               </a:tr>
-              <a:tr h="157480">
+              <a:tr h="170180">
                 <a:tc>
                   <a:txBody>
                     <a:bodyPr wrap="square"/>
@@ -5833,11 +5833,11 @@
                     <a:p>
                       <a:pPr algn="l">
                         <a:lnSpc>
-                          <a:spcPts val="800"/>
+                          <a:spcPts val="860"/>
                         </a:lnSpc>
                       </a:pPr>
                       <a:r>
-                        <a:rPr sz="640" b="0">
+                        <a:rPr sz="700" b="0">
                           <a:solidFill>
                             <a:srgbClr val="FEFEFF"/>
                           </a:solidFill>
@@ -5887,11 +5887,11 @@
                     <a:p>
                       <a:pPr algn="l">
                         <a:lnSpc>
-                          <a:spcPts val="800"/>
+                          <a:spcPts val="860"/>
                         </a:lnSpc>
                       </a:pPr>
                       <a:r>
-                        <a:rPr sz="640" b="0">
+                        <a:rPr sz="700" b="0">
                           <a:solidFill>
                             <a:srgbClr val="000000"/>
                           </a:solidFill>
@@ -5935,7 +5935,7 @@
                   </a:tcPr>
                 </a:tc>
               </a:tr>
-              <a:tr h="157480">
+              <a:tr h="170180">
                 <a:tc>
                   <a:txBody>
                     <a:bodyPr wrap="square"/>
@@ -5943,11 +5943,11 @@
                     <a:p>
                       <a:pPr algn="l">
                         <a:lnSpc>
-                          <a:spcPts val="800"/>
+                          <a:spcPts val="860"/>
                         </a:lnSpc>
                       </a:pPr>
                       <a:r>
-                        <a:rPr sz="640" b="0">
+                        <a:rPr sz="700" b="0">
                           <a:solidFill>
                             <a:srgbClr val="FEFEFF"/>
                           </a:solidFill>
@@ -5997,11 +5997,11 @@
                     <a:p>
                       <a:pPr algn="l">
                         <a:lnSpc>
-                          <a:spcPts val="800"/>
+                          <a:spcPts val="860"/>
                         </a:lnSpc>
                       </a:pPr>
                       <a:r>
-                        <a:rPr sz="640" b="0">
+                        <a:rPr sz="700" b="0">
                           <a:solidFill>
                             <a:srgbClr val="000000"/>
                           </a:solidFill>
@@ -6045,7 +6045,7 @@
                   </a:tcPr>
                 </a:tc>
               </a:tr>
-              <a:tr h="157480">
+              <a:tr h="170180">
                 <a:tc>
                   <a:txBody>
                     <a:bodyPr wrap="square"/>
@@ -6053,11 +6053,11 @@
                     <a:p>
                       <a:pPr algn="l">
                         <a:lnSpc>
-                          <a:spcPts val="800"/>
+                          <a:spcPts val="860"/>
                         </a:lnSpc>
                       </a:pPr>
                       <a:r>
-                        <a:rPr sz="640" b="0">
+                        <a:rPr sz="700" b="0">
                           <a:solidFill>
                             <a:srgbClr val="FEFEFF"/>
                           </a:solidFill>
@@ -6107,11 +6107,11 @@
                     <a:p>
                       <a:pPr algn="l">
                         <a:lnSpc>
-                          <a:spcPts val="800"/>
+                          <a:spcPts val="860"/>
                         </a:lnSpc>
                       </a:pPr>
                       <a:r>
-                        <a:rPr sz="640" b="0">
+                        <a:rPr sz="700" b="0">
                           <a:solidFill>
                             <a:srgbClr val="000000"/>
                           </a:solidFill>
@@ -6155,7 +6155,7 @@
                   </a:tcPr>
                 </a:tc>
               </a:tr>
-              <a:tr h="157480">
+              <a:tr h="170180">
                 <a:tc>
                   <a:txBody>
                     <a:bodyPr wrap="square"/>
@@ -6163,11 +6163,11 @@
                     <a:p>
                       <a:pPr algn="l">
                         <a:lnSpc>
-                          <a:spcPts val="800"/>
+                          <a:spcPts val="860"/>
                         </a:lnSpc>
                       </a:pPr>
                       <a:r>
-                        <a:rPr sz="640" b="0">
+                        <a:rPr sz="700" b="0">
                           <a:solidFill>
                             <a:srgbClr val="FEFEFF"/>
                           </a:solidFill>
@@ -6217,11 +6217,11 @@
                     <a:p>
                       <a:pPr algn="l">
                         <a:lnSpc>
-                          <a:spcPts val="800"/>
+                          <a:spcPts val="860"/>
                         </a:lnSpc>
                       </a:pPr>
                       <a:r>
-                        <a:rPr sz="640" b="0">
+                        <a:rPr sz="700" b="0">
                           <a:solidFill>
                             <a:srgbClr val="000000"/>
                           </a:solidFill>
@@ -6277,7 +6277,7 @@
         </p:nvSpPr>
         <p:spPr>
           <a:xfrm>
-            <a:off x="711200" y="7134859"/>
+            <a:off x="711200" y="7287259"/>
             <a:ext cx="6134100" cy="114300"/>
           </a:xfrm>
           <a:prstGeom prst="rect">
@@ -6319,7 +6319,7 @@
         </p:nvSpPr>
         <p:spPr>
           <a:xfrm>
-            <a:off x="711200" y="7312659"/>
+            <a:off x="711200" y="7465059"/>
             <a:ext cx="3009900" cy="177800"/>
           </a:xfrm>
           <a:prstGeom prst="rect">
@@ -6362,8 +6362,8 @@
           <p:nvPr/>
         </p:nvGraphicFramePr>
         <p:xfrm>
-          <a:off x="711200" y="7503159"/>
-          <a:ext cx="3009900" cy="990600"/>
+          <a:off x="711200" y="7655559"/>
+          <a:ext cx="3009900" cy="1168400"/>
         </p:xfrm>
         <a:graphic>
           <a:graphicData uri="http://schemas.openxmlformats.org/drawingml/2006/table">
@@ -6375,7 +6375,7 @@
                 <a:gridCol w="723900"/>
                 <a:gridCol w="711200"/>
               </a:tblGrid>
-              <a:tr h="152400">
+              <a:tr h="177800">
                 <a:tc>
                   <a:txBody>
                     <a:bodyPr wrap="square"/>
@@ -6383,11 +6383,11 @@
                     <a:p>
                       <a:pPr algn="ctr">
                         <a:lnSpc>
-                          <a:spcPts val="800"/>
+                          <a:spcPts val="860"/>
                         </a:lnSpc>
                       </a:pPr>
                       <a:r>
-                        <a:rPr sz="640" b="1">
+                        <a:rPr sz="700" b="1">
                           <a:solidFill>
                             <a:srgbClr val="FEFEFF"/>
                           </a:solidFill>
@@ -6437,11 +6437,11 @@
                     <a:p>
                       <a:pPr algn="ctr">
                         <a:lnSpc>
-                          <a:spcPts val="800"/>
+                          <a:spcPts val="860"/>
                         </a:lnSpc>
                       </a:pPr>
                       <a:r>
-                        <a:rPr sz="640" b="1">
+                        <a:rPr sz="700" b="1">
                           <a:solidFill>
                             <a:srgbClr val="FEFEFF"/>
                           </a:solidFill>
@@ -6491,11 +6491,11 @@
                     <a:p>
                       <a:pPr algn="ctr">
                         <a:lnSpc>
-                          <a:spcPts val="800"/>
+                          <a:spcPts val="860"/>
                         </a:lnSpc>
                       </a:pPr>
                       <a:r>
-                        <a:rPr sz="640" b="1">
+                        <a:rPr sz="700" b="1">
                           <a:solidFill>
                             <a:srgbClr val="FEFEFF"/>
                           </a:solidFill>
@@ -6545,11 +6545,11 @@
                     <a:p>
                       <a:pPr algn="ctr">
                         <a:lnSpc>
-                          <a:spcPts val="800"/>
+                          <a:spcPts val="860"/>
                         </a:lnSpc>
                       </a:pPr>
                       <a:r>
-                        <a:rPr sz="640" b="1">
+                        <a:rPr sz="700" b="1">
                           <a:solidFill>
                             <a:srgbClr val="FEFEFF"/>
                           </a:solidFill>
@@ -6593,7 +6593,7 @@
                   </a:tcPr>
                 </a:tc>
               </a:tr>
-              <a:tr h="139700">
+              <a:tr h="165100">
                 <a:tc>
                   <a:txBody>
                     <a:bodyPr wrap="square"/>
@@ -6601,11 +6601,11 @@
                     <a:p>
                       <a:pPr algn="ctr">
                         <a:lnSpc>
-                          <a:spcPts val="800"/>
+                          <a:spcPts val="860"/>
                         </a:lnSpc>
                       </a:pPr>
                       <a:r>
-                        <a:rPr sz="640" b="0">
+                        <a:rPr sz="700" b="0">
                           <a:solidFill>
                             <a:srgbClr val="FEFEFF"/>
                           </a:solidFill>
@@ -6655,11 +6655,11 @@
                     <a:p>
                       <a:pPr algn="ctr">
                         <a:lnSpc>
-                          <a:spcPts val="800"/>
+                          <a:spcPts val="860"/>
                         </a:lnSpc>
                       </a:pPr>
                       <a:r>
-                        <a:rPr sz="640" b="0">
+                        <a:rPr sz="700" b="0">
                           <a:solidFill>
                             <a:srgbClr val="000000"/>
                           </a:solidFill>
@@ -6709,11 +6709,11 @@
                     <a:p>
                       <a:pPr algn="ctr">
                         <a:lnSpc>
-                          <a:spcPts val="800"/>
+                          <a:spcPts val="860"/>
                         </a:lnSpc>
                       </a:pPr>
                       <a:r>
-                        <a:rPr sz="640" b="0">
+                        <a:rPr sz="700" b="0">
                           <a:solidFill>
                             <a:srgbClr val="000000"/>
                           </a:solidFill>
@@ -6763,11 +6763,11 @@
                     <a:p>
                       <a:pPr algn="ctr">
                         <a:lnSpc>
-                          <a:spcPts val="800"/>
+                          <a:spcPts val="860"/>
                         </a:lnSpc>
                       </a:pPr>
                       <a:r>
-                        <a:rPr sz="640" b="0">
+                        <a:rPr sz="700" b="0">
                           <a:solidFill>
                             <a:srgbClr val="000000"/>
                           </a:solidFill>
@@ -6811,7 +6811,7 @@
                   </a:tcPr>
                 </a:tc>
               </a:tr>
-              <a:tr h="139700">
+              <a:tr h="165100">
                 <a:tc>
                   <a:txBody>
                     <a:bodyPr wrap="square"/>
@@ -6819,11 +6819,11 @@
                     <a:p>
                       <a:pPr algn="ctr">
                         <a:lnSpc>
-                          <a:spcPts val="800"/>
+                          <a:spcPts val="860"/>
                         </a:lnSpc>
                       </a:pPr>
                       <a:r>
-                        <a:rPr sz="640" b="0">
+                        <a:rPr sz="700" b="0">
                           <a:solidFill>
                             <a:srgbClr val="FEFEFF"/>
                           </a:solidFill>
@@ -6873,11 +6873,11 @@
                     <a:p>
                       <a:pPr algn="ctr">
                         <a:lnSpc>
-                          <a:spcPts val="800"/>
+                          <a:spcPts val="860"/>
                         </a:lnSpc>
                       </a:pPr>
                       <a:r>
-                        <a:rPr sz="640" b="0">
+                        <a:rPr sz="700" b="0">
                           <a:solidFill>
                             <a:srgbClr val="000000"/>
                           </a:solidFill>
@@ -6927,11 +6927,11 @@
                     <a:p>
                       <a:pPr algn="ctr">
                         <a:lnSpc>
-                          <a:spcPts val="800"/>
+                          <a:spcPts val="860"/>
                         </a:lnSpc>
                       </a:pPr>
                       <a:r>
-                        <a:rPr sz="640" b="0">
+                        <a:rPr sz="700" b="0">
                           <a:solidFill>
                             <a:srgbClr val="000000"/>
                           </a:solidFill>
@@ -6981,11 +6981,11 @@
                     <a:p>
                       <a:pPr algn="ctr">
                         <a:lnSpc>
-                          <a:spcPts val="800"/>
+                          <a:spcPts val="860"/>
                         </a:lnSpc>
                       </a:pPr>
                       <a:r>
-                        <a:rPr sz="640" b="0">
+                        <a:rPr sz="700" b="0">
                           <a:solidFill>
                             <a:srgbClr val="000000"/>
                           </a:solidFill>
@@ -7029,7 +7029,7 @@
                   </a:tcPr>
                 </a:tc>
               </a:tr>
-              <a:tr h="139700">
+              <a:tr h="165100">
                 <a:tc>
                   <a:txBody>
                     <a:bodyPr wrap="square"/>
@@ -7037,11 +7037,11 @@
                     <a:p>
                       <a:pPr algn="ctr">
                         <a:lnSpc>
-                          <a:spcPts val="800"/>
+                          <a:spcPts val="860"/>
                         </a:lnSpc>
                       </a:pPr>
                       <a:r>
-                        <a:rPr sz="640" b="0">
+                        <a:rPr sz="700" b="0">
                           <a:solidFill>
                             <a:srgbClr val="FEFEFF"/>
                           </a:solidFill>
@@ -7091,11 +7091,11 @@
                     <a:p>
                       <a:pPr algn="ctr">
                         <a:lnSpc>
-                          <a:spcPts val="800"/>
+                          <a:spcPts val="860"/>
                         </a:lnSpc>
                       </a:pPr>
                       <a:r>
-                        <a:rPr sz="640" b="0">
+                        <a:rPr sz="700" b="0">
                           <a:solidFill>
                             <a:srgbClr val="000000"/>
                           </a:solidFill>
@@ -7145,11 +7145,11 @@
                     <a:p>
                       <a:pPr algn="ctr">
                         <a:lnSpc>
-                          <a:spcPts val="800"/>
+                          <a:spcPts val="860"/>
                         </a:lnSpc>
                       </a:pPr>
                       <a:r>
-                        <a:rPr sz="640" b="0">
+                        <a:rPr sz="700" b="0">
                           <a:solidFill>
                             <a:srgbClr val="000000"/>
                           </a:solidFill>
@@ -7199,11 +7199,11 @@
                     <a:p>
                       <a:pPr algn="ctr">
                         <a:lnSpc>
-                          <a:spcPts val="800"/>
+                          <a:spcPts val="860"/>
                         </a:lnSpc>
                       </a:pPr>
                       <a:r>
-                        <a:rPr sz="640" b="0">
+                        <a:rPr sz="700" b="0">
                           <a:solidFill>
                             <a:srgbClr val="000000"/>
                           </a:solidFill>
@@ -7247,7 +7247,7 @@
                   </a:tcPr>
                 </a:tc>
               </a:tr>
-              <a:tr h="139700">
+              <a:tr h="165100">
                 <a:tc>
                   <a:txBody>
                     <a:bodyPr wrap="square"/>
@@ -7255,11 +7255,11 @@
                     <a:p>
                       <a:pPr algn="ctr">
                         <a:lnSpc>
-                          <a:spcPts val="800"/>
+                          <a:spcPts val="860"/>
                         </a:lnSpc>
                       </a:pPr>
                       <a:r>
-                        <a:rPr sz="640" b="0">
+                        <a:rPr sz="700" b="0">
                           <a:solidFill>
                             <a:srgbClr val="FEFEFF"/>
                           </a:solidFill>
@@ -7309,11 +7309,11 @@
                     <a:p>
                       <a:pPr algn="ctr">
                         <a:lnSpc>
-                          <a:spcPts val="800"/>
+                          <a:spcPts val="860"/>
                         </a:lnSpc>
                       </a:pPr>
                       <a:r>
-                        <a:rPr sz="640" b="0">
+                        <a:rPr sz="700" b="0">
                           <a:solidFill>
                             <a:srgbClr val="000000"/>
                           </a:solidFill>
@@ -7363,11 +7363,11 @@
                     <a:p>
                       <a:pPr algn="ctr">
                         <a:lnSpc>
-                          <a:spcPts val="800"/>
+                          <a:spcPts val="860"/>
                         </a:lnSpc>
                       </a:pPr>
                       <a:r>
-                        <a:rPr sz="640" b="0">
+                        <a:rPr sz="700" b="0">
                           <a:solidFill>
                             <a:srgbClr val="000000"/>
                           </a:solidFill>
@@ -7417,11 +7417,11 @@
                     <a:p>
                       <a:pPr algn="ctr">
                         <a:lnSpc>
-                          <a:spcPts val="800"/>
+                          <a:spcPts val="860"/>
                         </a:lnSpc>
                       </a:pPr>
                       <a:r>
-                        <a:rPr sz="640" b="0">
+                        <a:rPr sz="700" b="0">
                           <a:solidFill>
                             <a:srgbClr val="000000"/>
                           </a:solidFill>
@@ -7465,7 +7465,7 @@
                   </a:tcPr>
                 </a:tc>
               </a:tr>
-              <a:tr h="139700">
+              <a:tr h="165100">
                 <a:tc>
                   <a:txBody>
                     <a:bodyPr wrap="square"/>
@@ -7473,11 +7473,11 @@
                     <a:p>
                       <a:pPr algn="ctr">
                         <a:lnSpc>
-                          <a:spcPts val="800"/>
+                          <a:spcPts val="860"/>
                         </a:lnSpc>
                       </a:pPr>
                       <a:r>
-                        <a:rPr sz="640" b="0">
+                        <a:rPr sz="700" b="0">
                           <a:solidFill>
                             <a:srgbClr val="FEFEFF"/>
                           </a:solidFill>
@@ -7527,11 +7527,11 @@
                     <a:p>
                       <a:pPr algn="ctr">
                         <a:lnSpc>
-                          <a:spcPts val="800"/>
+                          <a:spcPts val="860"/>
                         </a:lnSpc>
                       </a:pPr>
                       <a:r>
-                        <a:rPr sz="640" b="0">
+                        <a:rPr sz="700" b="0">
                           <a:solidFill>
                             <a:srgbClr val="000000"/>
                           </a:solidFill>
@@ -7581,11 +7581,11 @@
                     <a:p>
                       <a:pPr algn="ctr">
                         <a:lnSpc>
-                          <a:spcPts val="800"/>
+                          <a:spcPts val="860"/>
                         </a:lnSpc>
                       </a:pPr>
                       <a:r>
-                        <a:rPr sz="640" b="0">
+                        <a:rPr sz="700" b="0">
                           <a:solidFill>
                             <a:srgbClr val="000000"/>
                           </a:solidFill>
@@ -7635,11 +7635,11 @@
                     <a:p>
                       <a:pPr algn="ctr">
                         <a:lnSpc>
-                          <a:spcPts val="800"/>
+                          <a:spcPts val="860"/>
                         </a:lnSpc>
                       </a:pPr>
                       <a:r>
-                        <a:rPr sz="640" b="0">
+                        <a:rPr sz="700" b="0">
                           <a:solidFill>
                             <a:srgbClr val="000000"/>
                           </a:solidFill>
@@ -7683,7 +7683,7 @@
                   </a:tcPr>
                 </a:tc>
               </a:tr>
-              <a:tr h="139700">
+              <a:tr h="165100">
                 <a:tc>
                   <a:txBody>
                     <a:bodyPr wrap="square"/>
@@ -7691,11 +7691,11 @@
                     <a:p>
                       <a:pPr algn="ctr">
                         <a:lnSpc>
-                          <a:spcPts val="800"/>
+                          <a:spcPts val="860"/>
                         </a:lnSpc>
                       </a:pPr>
                       <a:r>
-                        <a:rPr sz="640" b="0">
+                        <a:rPr sz="700" b="0">
                           <a:solidFill>
                             <a:srgbClr val="FEFEFF"/>
                           </a:solidFill>
@@ -7745,11 +7745,11 @@
                     <a:p>
                       <a:pPr algn="ctr">
                         <a:lnSpc>
-                          <a:spcPts val="800"/>
+                          <a:spcPts val="860"/>
                         </a:lnSpc>
                       </a:pPr>
                       <a:r>
-                        <a:rPr sz="640" b="0">
+                        <a:rPr sz="700" b="0">
                           <a:solidFill>
                             <a:srgbClr val="000000"/>
                           </a:solidFill>
@@ -7799,11 +7799,11 @@
                     <a:p>
                       <a:pPr algn="ctr">
                         <a:lnSpc>
-                          <a:spcPts val="800"/>
+                          <a:spcPts val="860"/>
                         </a:lnSpc>
                       </a:pPr>
                       <a:r>
-                        <a:rPr sz="640" b="0">
+                        <a:rPr sz="700" b="0">
                           <a:solidFill>
                             <a:srgbClr val="000000"/>
                           </a:solidFill>
@@ -7853,11 +7853,11 @@
                     <a:p>
                       <a:pPr algn="ctr">
                         <a:lnSpc>
-                          <a:spcPts val="800"/>
+                          <a:spcPts val="860"/>
                         </a:lnSpc>
                       </a:pPr>
                       <a:r>
-                        <a:rPr sz="640" b="0">
+                        <a:rPr sz="700" b="0">
                           <a:solidFill>
                             <a:srgbClr val="000000"/>
                           </a:solidFill>
@@ -7913,7 +7913,7 @@
         </p:nvSpPr>
         <p:spPr>
           <a:xfrm>
-            <a:off x="711200" y="8595360"/>
+            <a:off x="711200" y="8950960"/>
             <a:ext cx="3009900" cy="177800"/>
           </a:xfrm>
           <a:prstGeom prst="rect">
@@ -7955,7 +7955,7 @@
         </p:nvSpPr>
         <p:spPr>
           <a:xfrm>
-            <a:off x="711200" y="8785860"/>
+            <a:off x="711200" y="9141460"/>
             <a:ext cx="3009900" cy="762000"/>
           </a:xfrm>
           <a:prstGeom prst="rect">
@@ -7971,14 +7971,14 @@
           <a:p>
             <a:pPr algn="just">
               <a:lnSpc>
-                <a:spcPts val="840"/>
+                <a:spcPts val="940"/>
               </a:lnSpc>
               <a:spcAft>
                 <a:spcPts val="0"/>
               </a:spcAft>
             </a:pPr>
             <a:r>
-              <a:rPr sz="660" b="0">
+              <a:rPr sz="720" b="0">
                 <a:solidFill>
                   <a:srgbClr val="000000"/>
                 </a:solidFill>
@@ -8000,7 +8000,7 @@
         </p:nvSpPr>
         <p:spPr>
           <a:xfrm>
-            <a:off x="3835400" y="7312659"/>
+            <a:off x="3835400" y="7465059"/>
             <a:ext cx="3009900" cy="177800"/>
           </a:xfrm>
           <a:prstGeom prst="rect">
@@ -8042,7 +8042,7 @@
         </p:nvSpPr>
         <p:spPr>
           <a:xfrm>
-            <a:off x="3835400" y="7515859"/>
+            <a:off x="3835400" y="7668259"/>
             <a:ext cx="3009900" cy="127000"/>
           </a:xfrm>
           <a:prstGeom prst="rect">
@@ -8058,14 +8058,14 @@
           <a:p>
             <a:pPr algn="l">
               <a:lnSpc>
-                <a:spcPts val="880"/>
+                <a:spcPts val="900"/>
               </a:lnSpc>
               <a:spcAft>
-                <a:spcPts val="200"/>
+                <a:spcPts val="240"/>
               </a:spcAft>
             </a:pPr>
             <a:r>
-              <a:rPr sz="550" b="0">
+              <a:rPr sz="560" b="0">
                 <a:solidFill>
                   <a:srgbClr val="01ADEE"/>
                 </a:solidFill>
@@ -8077,7 +8077,7 @@
               <a:t>■ </a:t>
             </a:r>
             <a:r>
-              <a:rPr sz="700" b="1">
+              <a:rPr sz="710" b="1">
                 <a:solidFill>
                   <a:srgbClr val="000000"/>
                 </a:solidFill>
@@ -8089,7 +8089,7 @@
               <a:t>Field-proven design: </a:t>
             </a:r>
             <a:r>
-              <a:rPr sz="700" b="0">
+              <a:rPr sz="710" b="0">
                 <a:solidFill>
                   <a:srgbClr val="000000"/>
                 </a:solidFill>
@@ -8104,14 +8104,14 @@
           <a:p>
             <a:pPr algn="l">
               <a:lnSpc>
-                <a:spcPts val="880"/>
+                <a:spcPts val="900"/>
               </a:lnSpc>
               <a:spcAft>
-                <a:spcPts val="200"/>
+                <a:spcPts val="240"/>
               </a:spcAft>
             </a:pPr>
             <a:r>
-              <a:rPr sz="550" b="0">
+              <a:rPr sz="560" b="0">
                 <a:solidFill>
                   <a:srgbClr val="01ADEE"/>
                 </a:solidFill>
@@ -8123,7 +8123,7 @@
               <a:t>■ </a:t>
             </a:r>
             <a:r>
-              <a:rPr sz="700" b="1">
+              <a:rPr sz="710" b="1">
                 <a:solidFill>
                   <a:srgbClr val="000000"/>
                 </a:solidFill>
@@ -8135,7 +8135,7 @@
               <a:t>Anti-plugging pulser: </a:t>
             </a:r>
             <a:r>
-              <a:rPr sz="700" b="0">
+              <a:rPr sz="710" b="0">
                 <a:solidFill>
                   <a:srgbClr val="000000"/>
                 </a:solidFill>
@@ -8150,14 +8150,14 @@
           <a:p>
             <a:pPr algn="l">
               <a:lnSpc>
-                <a:spcPts val="880"/>
+                <a:spcPts val="900"/>
               </a:lnSpc>
               <a:spcAft>
-                <a:spcPts val="200"/>
+                <a:spcPts val="240"/>
               </a:spcAft>
             </a:pPr>
             <a:r>
-              <a:rPr sz="550" b="0">
+              <a:rPr sz="560" b="0">
                 <a:solidFill>
                   <a:srgbClr val="01ADEE"/>
                 </a:solidFill>
@@ -8169,7 +8169,7 @@
               <a:t>■ </a:t>
             </a:r>
             <a:r>
-              <a:rPr sz="700" b="1">
+              <a:rPr sz="710" b="1">
                 <a:solidFill>
                   <a:srgbClr val="000000"/>
                 </a:solidFill>
@@ -8181,7 +8181,7 @@
               <a:t>Simple operation: </a:t>
             </a:r>
             <a:r>
-              <a:rPr sz="700" b="0">
+              <a:rPr sz="710" b="0">
                 <a:solidFill>
                   <a:srgbClr val="000000"/>
                 </a:solidFill>
@@ -8196,14 +8196,14 @@
           <a:p>
             <a:pPr algn="l">
               <a:lnSpc>
-                <a:spcPts val="880"/>
+                <a:spcPts val="900"/>
               </a:lnSpc>
               <a:spcAft>
-                <a:spcPts val="200"/>
+                <a:spcPts val="240"/>
               </a:spcAft>
             </a:pPr>
             <a:r>
-              <a:rPr sz="550" b="0">
+              <a:rPr sz="560" b="0">
                 <a:solidFill>
                   <a:srgbClr val="01ADEE"/>
                 </a:solidFill>
@@ -8215,7 +8215,7 @@
               <a:t>■ </a:t>
             </a:r>
             <a:r>
-              <a:rPr sz="700" b="1">
+              <a:rPr sz="710" b="1">
                 <a:solidFill>
                   <a:srgbClr val="000000"/>
                 </a:solidFill>
@@ -8227,7 +8227,7 @@
               <a:t>Ratcheting military connector: </a:t>
             </a:r>
             <a:r>
-              <a:rPr sz="700" b="0">
+              <a:rPr sz="710" b="0">
                 <a:solidFill>
                   <a:srgbClr val="000000"/>
                 </a:solidFill>
@@ -8242,14 +8242,14 @@
           <a:p>
             <a:pPr algn="l">
               <a:lnSpc>
-                <a:spcPts val="880"/>
+                <a:spcPts val="900"/>
               </a:lnSpc>
               <a:spcAft>
-                <a:spcPts val="200"/>
+                <a:spcPts val="240"/>
               </a:spcAft>
             </a:pPr>
             <a:r>
-              <a:rPr sz="550" b="0">
+              <a:rPr sz="560" b="0">
                 <a:solidFill>
                   <a:srgbClr val="01ADEE"/>
                 </a:solidFill>
@@ -8261,7 +8261,7 @@
               <a:t>■ </a:t>
             </a:r>
             <a:r>
-              <a:rPr sz="700" b="1">
+              <a:rPr sz="710" b="1">
                 <a:solidFill>
                   <a:srgbClr val="000000"/>
                 </a:solidFill>
@@ -8273,7 +8273,7 @@
               <a:t>Stable in the hole: </a:t>
             </a:r>
             <a:r>
-              <a:rPr sz="700" b="0">
+              <a:rPr sz="710" b="0">
                 <a:solidFill>
                   <a:srgbClr val="000000"/>
                 </a:solidFill>
@@ -8288,14 +8288,14 @@
           <a:p>
             <a:pPr algn="l">
               <a:lnSpc>
-                <a:spcPts val="880"/>
+                <a:spcPts val="900"/>
               </a:lnSpc>
               <a:spcAft>
-                <a:spcPts val="200"/>
+                <a:spcPts val="240"/>
               </a:spcAft>
             </a:pPr>
             <a:r>
-              <a:rPr sz="550" b="0">
+              <a:rPr sz="560" b="0">
                 <a:solidFill>
                   <a:srgbClr val="01ADEE"/>
                 </a:solidFill>
@@ -8307,7 +8307,7 @@
               <a:t>■ </a:t>
             </a:r>
             <a:r>
-              <a:rPr sz="700" b="1">
+              <a:rPr sz="710" b="1">
                 <a:solidFill>
                   <a:srgbClr val="000000"/>
                 </a:solidFill>
@@ -8319,7 +8319,7 @@
               <a:t>Custom configuration: </a:t>
             </a:r>
             <a:r>
-              <a:rPr sz="700" b="0">
+              <a:rPr sz="710" b="0">
                 <a:solidFill>
                   <a:srgbClr val="000000"/>
                 </a:solidFill>
@@ -8333,9 +8333,96 @@
           </a:p>
         </p:txBody>
       </p:sp>
+      <p:sp>
+        <p:nvSpPr>
+          <p:cNvPr id="31" name="TextBox 30"/>
+          <p:cNvSpPr txBox="1"/>
+          <p:nvPr/>
+        </p:nvSpPr>
+        <p:spPr>
+          <a:xfrm>
+            <a:off x="3835400" y="9166860"/>
+            <a:ext cx="3009900" cy="177800"/>
+          </a:xfrm>
+          <a:prstGeom prst="rect">
+            <a:avLst/>
+          </a:prstGeom>
+          <a:noFill/>
+        </p:spPr>
+        <p:txBody>
+          <a:bodyPr wrap="square" lIns="0" rIns="0" tIns="0" bIns="0">
+            <a:spAutoFit/>
+          </a:bodyPr>
+          <a:lstStyle/>
+          <a:p>
+            <a:pPr algn="ctr">
+              <a:spcAft>
+                <a:spcPts val="0"/>
+              </a:spcAft>
+            </a:pPr>
+            <a:r>
+              <a:rPr sz="1050" b="1" spc="20">
+                <a:solidFill>
+                  <a:srgbClr val="194E9A"/>
+                </a:solidFill>
+                <a:latin typeface="Ubuntu Mono"/>
+                <a:ea typeface="Ubuntu Mono"/>
+                <a:cs typeface="Ubuntu Mono"/>
+                <a:sym typeface="Ubuntu Mono"/>
+              </a:rPr>
+              <a:t>HOW TO ORDER</a:t>
+            </a:r>
+          </a:p>
+        </p:txBody>
+      </p:sp>
+      <p:sp>
+        <p:nvSpPr>
+          <p:cNvPr id="32" name="TextBox 31"/>
+          <p:cNvSpPr txBox="1"/>
+          <p:nvPr/>
+        </p:nvSpPr>
+        <p:spPr>
+          <a:xfrm>
+            <a:off x="3835400" y="9357360"/>
+            <a:ext cx="3009900" cy="635000"/>
+          </a:xfrm>
+          <a:prstGeom prst="rect">
+            <a:avLst/>
+          </a:prstGeom>
+          <a:noFill/>
+        </p:spPr>
+        <p:txBody>
+          <a:bodyPr wrap="square" lIns="0" rIns="0" tIns="0" bIns="0">
+            <a:spAutoFit/>
+          </a:bodyPr>
+          <a:lstStyle/>
+          <a:p>
+            <a:pPr algn="just">
+              <a:lnSpc>
+                <a:spcPts val="840"/>
+              </a:lnSpc>
+              <a:spcAft>
+                <a:spcPts val="0"/>
+              </a:spcAft>
+            </a:pPr>
+            <a:r>
+              <a:rPr sz="660" b="0">
+                <a:solidFill>
+                  <a:srgbClr val="000000"/>
+                </a:solidFill>
+                <a:latin typeface="Ubuntu Mono"/>
+                <a:ea typeface="Ubuntu Mono"/>
+                <a:cs typeface="Ubuntu Mono"/>
+                <a:sym typeface="Ubuntu Mono"/>
+              </a:rPr>
+              <a:t>Please specify: 1. collar size  2. top or bottom mounted version  3. 1 or 2 battery modules  4. temperature rating (185 °C standard, 200 °C option)  5. sensor options (e.g. orbital gamma) and logging sequences.</a:t>
+            </a:r>
+          </a:p>
+        </p:txBody>
+      </p:sp>
       <p:pic>
         <p:nvPicPr>
-          <p:cNvPr id="31" name="Picture 30" descr="mwd_tool_blue.png"/>
+          <p:cNvPr id="33" name="Picture 32" descr="mwd_tool_blue.png"/>
           <p:cNvPicPr>
             <a:picLocks noChangeAspect="1"/>
           </p:cNvPicPr>
@@ -8349,101 +8436,14 @@
         </p:blipFill>
         <p:spPr>
           <a:xfrm>
-            <a:off x="965200" y="9420860"/>
-            <a:ext cx="2159000" cy="1243747"/>
+            <a:off x="4597400" y="9725660"/>
+            <a:ext cx="1333500" cy="768197"/>
           </a:xfrm>
           <a:prstGeom prst="rect">
             <a:avLst/>
           </a:prstGeom>
         </p:spPr>
       </p:pic>
-      <p:sp>
-        <p:nvSpPr>
-          <p:cNvPr id="32" name="TextBox 31"/>
-          <p:cNvSpPr txBox="1"/>
-          <p:nvPr/>
-        </p:nvSpPr>
-        <p:spPr>
-          <a:xfrm>
-            <a:off x="3835400" y="9045956"/>
-            <a:ext cx="3009900" cy="177800"/>
-          </a:xfrm>
-          <a:prstGeom prst="rect">
-            <a:avLst/>
-          </a:prstGeom>
-          <a:noFill/>
-        </p:spPr>
-        <p:txBody>
-          <a:bodyPr wrap="square" lIns="0" rIns="0" tIns="0" bIns="0">
-            <a:spAutoFit/>
-          </a:bodyPr>
-          <a:lstStyle/>
-          <a:p>
-            <a:pPr algn="ctr">
-              <a:spcAft>
-                <a:spcPts val="0"/>
-              </a:spcAft>
-            </a:pPr>
-            <a:r>
-              <a:rPr sz="1050" b="1" spc="20">
-                <a:solidFill>
-                  <a:srgbClr val="194E9A"/>
-                </a:solidFill>
-                <a:latin typeface="Ubuntu Mono"/>
-                <a:ea typeface="Ubuntu Mono"/>
-                <a:cs typeface="Ubuntu Mono"/>
-                <a:sym typeface="Ubuntu Mono"/>
-              </a:rPr>
-              <a:t>HOW TO ORDER</a:t>
-            </a:r>
-          </a:p>
-        </p:txBody>
-      </p:sp>
-      <p:sp>
-        <p:nvSpPr>
-          <p:cNvPr id="33" name="TextBox 32"/>
-          <p:cNvSpPr txBox="1"/>
-          <p:nvPr/>
-        </p:nvSpPr>
-        <p:spPr>
-          <a:xfrm>
-            <a:off x="3835400" y="9236456"/>
-            <a:ext cx="3009900" cy="635000"/>
-          </a:xfrm>
-          <a:prstGeom prst="rect">
-            <a:avLst/>
-          </a:prstGeom>
-          <a:noFill/>
-        </p:spPr>
-        <p:txBody>
-          <a:bodyPr wrap="square" lIns="0" rIns="0" tIns="0" bIns="0">
-            <a:spAutoFit/>
-          </a:bodyPr>
-          <a:lstStyle/>
-          <a:p>
-            <a:pPr algn="just">
-              <a:lnSpc>
-                <a:spcPts val="840"/>
-              </a:lnSpc>
-              <a:spcAft>
-                <a:spcPts val="0"/>
-              </a:spcAft>
-            </a:pPr>
-            <a:r>
-              <a:rPr sz="660" b="0">
-                <a:solidFill>
-                  <a:srgbClr val="000000"/>
-                </a:solidFill>
-                <a:latin typeface="Ubuntu Mono"/>
-                <a:ea typeface="Ubuntu Mono"/>
-                <a:cs typeface="Ubuntu Mono"/>
-                <a:sym typeface="Ubuntu Mono"/>
-              </a:rPr>
-              <a:t>Please specify: 1. collar size  2. top or bottom mounted version  3. 1 or 2 battery modules  4. temperature rating (185 °C standard, 200 °C option)  5. sensor options (e.g. orbital gamma) and logging sequences.</a:t>
-            </a:r>
-          </a:p>
-        </p:txBody>
-      </p:sp>
     </p:spTree>
   </p:cSld>
   <p:clrMapOvr>

</xml_diff>

<commit_message>
Fiches outils: Pipe Cutter, MWD et mises à jour
Co-Authored-By: Claude Sonnet 5.5 <noreply@anthropic.com>
Claude-Session: https://claude.ai/code/session_01XPwnZBmWUGhvYebrP3X3Z2
</commit_message>
<xml_diff>
--- a/fiches_outils/Fiche_technique_MWD.pptx
+++ b/fiches_outils/Fiche_technique_MWD.pptx
@@ -8436,8 +8436,8 @@
         </p:blipFill>
         <p:spPr>
           <a:xfrm>
-            <a:off x="4597400" y="9725660"/>
-            <a:ext cx="1333500" cy="768197"/>
+            <a:off x="4724400" y="9687560"/>
+            <a:ext cx="1168400" cy="673087"/>
           </a:xfrm>
           <a:prstGeom prst="rect">
             <a:avLst/>

</xml_diff>